<commit_message>
Make logical-arch slide refresh idempotent (in-place picture swap)
Previous version of the script DELETED the existing slide and added a
new one - python-pptx's slide delete leaves orphan parts in the
package which corrupted the slide order (lost References slide,
duplicated Logical Architecture slide).

New approach:
* If a slide titled 'Logical Architecture (C4 L2)' already exists:
  remove its picture shapes only, then add the new picture. Slide
  position and title-textbox stay put.
* If the slide doesn't exist yet: add a fresh one and reorder it to
  position 5.

Verified: all 8 slides intact after refresh, References slide
preserved, picture replaced on slide 5.

Re-run anytime after re-exporting the drawio PNG - it will swap the
image in place.

Co-Authored-By: Claude Opus 4.7 (1M context) <noreply@anthropic.com>
</commit_message>
<xml_diff>
--- a/docs/hackathon_blueprint_filled.pptx
+++ b/docs/hackathon_blueprint_filled.pptx
@@ -5114,6 +5114,77 @@
 </file>
 
 <file path=ppt/slides/slide5.xml><?xml version="1.0" encoding="utf-8"?>
+<p:sld xmlns:a="http://schemas.openxmlformats.org/drawingml/2006/main" xmlns:p="http://schemas.openxmlformats.org/presentationml/2006/main" xmlns:r="http://schemas.openxmlformats.org/officeDocument/2006/relationships">
+  <p:cSld>
+    <p:spTree>
+      <p:nvGrpSpPr>
+        <p:cNvPr id="1" name=""/>
+        <p:cNvGrpSpPr/>
+        <p:nvPr/>
+      </p:nvGrpSpPr>
+      <p:grpSpPr/>
+      <p:sp>
+        <p:nvSpPr>
+          <p:cNvPr id="3" name="TextBox 2"/>
+          <p:cNvSpPr txBox="1"/>
+          <p:nvPr/>
+        </p:nvSpPr>
+        <p:spPr>
+          <a:xfrm>
+            <a:off x="137160" y="45720"/>
+            <a:ext cx="5486400" cy="320040"/>
+          </a:xfrm>
+          <a:prstGeom prst="rect">
+            <a:avLst/>
+          </a:prstGeom>
+          <a:noFill/>
+        </p:spPr>
+        <p:txBody>
+          <a:bodyPr wrap="none">
+            <a:spAutoFit/>
+          </a:bodyPr>
+          <a:lstStyle/>
+          <a:p>
+            <a:r>
+              <a:rPr sz="1296" b="1"/>
+              <a:t>Logical Architecture (C4 L2)</a:t>
+            </a:r>
+          </a:p>
+        </p:txBody>
+      </p:sp>
+      <p:pic>
+        <p:nvPicPr>
+          <p:cNvPr id="4" name="Picture 3" descr="image.png"/>
+          <p:cNvPicPr>
+            <a:picLocks noChangeAspect="1"/>
+          </p:cNvPicPr>
+          <p:nvPr/>
+        </p:nvPicPr>
+        <p:blipFill>
+          <a:blip r:embed="rId2"/>
+          <a:stretch>
+            <a:fillRect/>
+          </a:stretch>
+        </p:blipFill>
+        <p:spPr>
+          <a:xfrm>
+            <a:off x="0" y="63415"/>
+            <a:ext cx="9144000" cy="5016670"/>
+          </a:xfrm>
+          <a:prstGeom prst="rect">
+            <a:avLst/>
+          </a:prstGeom>
+        </p:spPr>
+      </p:pic>
+    </p:spTree>
+  </p:cSld>
+  <p:clrMapOvr>
+    <a:masterClrMapping/>
+  </p:clrMapOvr>
+</p:sld>
+</file>
+
+<file path=ppt/slides/slide6.xml><?xml version="1.0" encoding="utf-8"?>
 <p:sld xmlns:a="http://schemas.openxmlformats.org/drawingml/2006/main" xmlns:r="http://schemas.openxmlformats.org/officeDocument/2006/relationships" xmlns:p="http://schemas.openxmlformats.org/presentationml/2006/main">
   <p:cSld>
     <p:spTree>
@@ -8292,7 +8363,7 @@
 </p:sld>
 </file>
 
-<file path=ppt/slides/slide6.xml><?xml version="1.0" encoding="utf-8"?>
+<file path=ppt/slides/slide7.xml><?xml version="1.0" encoding="utf-8"?>
 <p:sld xmlns:a="http://schemas.openxmlformats.org/drawingml/2006/main" xmlns:r="http://schemas.openxmlformats.org/officeDocument/2006/relationships" xmlns:p="http://schemas.openxmlformats.org/presentationml/2006/main">
   <p:cSld name="Slide 4">
     <p:bg>
@@ -9842,7 +9913,7 @@
 </p:sld>
 </file>
 
-<file path=ppt/slides/slide7.xml><?xml version="1.0" encoding="utf-8"?>
+<file path=ppt/slides/slide8.xml><?xml version="1.0" encoding="utf-8"?>
 <p:sld xmlns:a="http://schemas.openxmlformats.org/drawingml/2006/main" xmlns:r="http://schemas.openxmlformats.org/officeDocument/2006/relationships" xmlns:p="http://schemas.openxmlformats.org/presentationml/2006/main">
   <p:cSld name="Slide 5">
     <p:bg>
@@ -10516,77 +10587,6 @@
         <p14:creationId xmlns:p14="http://schemas.microsoft.com/office/powerpoint/2010/main" val="1287356172"/>
       </p:ext>
     </p:extLst>
-  </p:cSld>
-  <p:clrMapOvr>
-    <a:masterClrMapping/>
-  </p:clrMapOvr>
-</p:sld>
-</file>
-
-<file path=ppt/slides/slide8.xml><?xml version="1.0" encoding="utf-8"?>
-<p:sld xmlns:a="http://schemas.openxmlformats.org/drawingml/2006/main" xmlns:p="http://schemas.openxmlformats.org/presentationml/2006/main" xmlns:r="http://schemas.openxmlformats.org/officeDocument/2006/relationships">
-  <p:cSld>
-    <p:spTree>
-      <p:nvGrpSpPr>
-        <p:cNvPr id="1" name=""/>
-        <p:cNvGrpSpPr/>
-        <p:nvPr/>
-      </p:nvGrpSpPr>
-      <p:grpSpPr/>
-      <p:pic>
-        <p:nvPicPr>
-          <p:cNvPr id="2" name="Picture 1" descr="02_logical_architecture.drawio.png"/>
-          <p:cNvPicPr>
-            <a:picLocks noChangeAspect="1"/>
-          </p:cNvPicPr>
-          <p:nvPr/>
-        </p:nvPicPr>
-        <p:blipFill>
-          <a:blip r:embed="rId2"/>
-          <a:stretch>
-            <a:fillRect/>
-          </a:stretch>
-        </p:blipFill>
-        <p:spPr>
-          <a:xfrm>
-            <a:off x="0" y="63415"/>
-            <a:ext cx="9144000" cy="5016670"/>
-          </a:xfrm>
-          <a:prstGeom prst="rect">
-            <a:avLst/>
-          </a:prstGeom>
-        </p:spPr>
-      </p:pic>
-      <p:sp>
-        <p:nvSpPr>
-          <p:cNvPr id="3" name="TextBox 2"/>
-          <p:cNvSpPr txBox="1"/>
-          <p:nvPr/>
-        </p:nvSpPr>
-        <p:spPr>
-          <a:xfrm>
-            <a:off x="137160" y="45720"/>
-            <a:ext cx="5486400" cy="320040"/>
-          </a:xfrm>
-          <a:prstGeom prst="rect">
-            <a:avLst/>
-          </a:prstGeom>
-          <a:noFill/>
-        </p:spPr>
-        <p:txBody>
-          <a:bodyPr wrap="none">
-            <a:spAutoFit/>
-          </a:bodyPr>
-          <a:lstStyle/>
-          <a:p>
-            <a:r>
-              <a:rPr sz="1296" b="1"/>
-              <a:t>Logical Architecture (C4 L2)</a:t>
-            </a:r>
-          </a:p>
-        </p:txBody>
-      </p:sp>
-    </p:spTree>
   </p:cSld>
   <p:clrMapOvr>
     <a:masterClrMapping/>

</xml_diff>